<commit_message>
Stage 8 review fixes: B-031
</commit_message>
<xml_diff>
--- a/output/archive/Archive/Users/mellerscombe_old_laptop/Training/Plate_acceptance/Plate_acceptance_training_v2.pptx
+++ b/output/archive/Archive/Users/mellerscombe_old_laptop/Training/Plate_acceptance/Plate_acceptance_training_v2.pptx
@@ -650,7 +650,7 @@
           <a:lstStyle/>
           <a:p>
             <a:r>
-              <a:t>MS: the drift chart template is on the shared drive under Biology. The old copy in my folder is out of date.</a:t>
+              <a:t>ME: the drift chart template is on the shared drive under Biology. The old copy in my folder is out of date.</a:t>
             </a:r>
           </a:p>
         </p:txBody>
@@ -720,7 +720,7 @@
           <a:lstStyle/>
           <a:p>
             <a:r>
-              <a:t>Still unclear whether the one-rerun rule applies to the hepatocyte plates. Ask Anika before the course.</a:t>
+              <a:t>Reviewer query for Anika: confirm repeat limits for this assay before the next course; do not apply these slides to hepatocyte work.</a:t>
             </a:r>
           </a:p>
         </p:txBody>
@@ -4204,7 +4204,7 @@
               <a:rPr sz="1700">
                 <a:latin typeface="Times New Roman"/>
               </a:rPr>
-              <a:t>Staurosporine is the house reference for this assay</a:t>
+              <a:t>Use the reference inhibitor specified in the assay protocol</a:t>
             </a:r>
           </a:p>
         </p:txBody>
@@ -4364,7 +4364,7 @@
               <a:rPr sz="2000">
                 <a:latin typeface="Times New Roman"/>
               </a:rPr>
-              <a:t>Plot the positive and negative control signal against plate order</a:t>
+              <a:t>Plot the positive and negative control signals against plate order</a:t>
             </a:r>
           </a:p>
           <a:p>
@@ -4373,7 +4373,7 @@
               <a:rPr sz="2000">
                 <a:latin typeface="Times New Roman"/>
               </a:rPr>
-              <a:t>A slow drift across the set is a reagent or temperature question</a:t>
+              <a:t>Investigate gradual drift for reagent, timing or temperature effects</a:t>
             </a:r>
           </a:p>
           <a:p>
@@ -4382,7 +4382,7 @@
               <a:rPr sz="1700">
                 <a:latin typeface="Times New Roman"/>
               </a:rPr>
-              <a:t>Look at the incubator log before reading the compounds</a:t>
+              <a:t>Check the run sheet and temperature record before interpreting compounds</a:t>
             </a:r>
           </a:p>
           <a:p>
@@ -4391,7 +4391,7 @@
               <a:rPr sz="2000">
                 <a:latin typeface="Times New Roman"/>
               </a:rPr>
-              <a:t>A step change between two plates usually means a new reagent lot</a:t>
+              <a:t>Investigate a step change; do not assume a reagent lot is the cause</a:t>
             </a:r>
           </a:p>
           <a:p>
@@ -4400,7 +4400,7 @@
               <a:rPr sz="1700">
                 <a:latin typeface="Times New Roman"/>
               </a:rPr>
-              <a:t>Record the test lot number on the run sheet</a:t>
+              <a:t>Check reagent lot and preparation entries on the run sheet</a:t>
             </a:r>
           </a:p>
           <a:p>
@@ -4409,7 +4409,7 @@
               <a:rPr sz="2000">
                 <a:latin typeface="Times New Roman"/>
               </a:rPr>
-              <a:t>Drift alone does not fail a plate if both controls still sit inside the window</a:t>
+              <a:t>Release only when all protocol acceptance criteria, including drift checks, are met</a:t>
             </a:r>
           </a:p>
         </p:txBody>
@@ -4569,7 +4569,7 @@
               <a:rPr sz="1800">
                 <a:latin typeface="Times New Roman"/>
               </a:rPr>
-              <a:t>Accept when both controls are inside the window</a:t>
+              <a:t>Accept only when all protocol control and reference-response criteria are met</a:t>
             </a:r>
           </a:p>
           <a:p>
@@ -4578,7 +4578,7 @@
               <a:rPr sz="1800">
                 <a:latin typeface="Times New Roman"/>
               </a:rPr>
-              <a:t>Accept when the reference dose response falls on its curve</a:t>
+              <a:t>Check reference potency and curve quality against the defined acceptance limits</a:t>
             </a:r>
           </a:p>
           <a:p>
@@ -4587,7 +4587,7 @@
               <a:rPr sz="1800">
                 <a:latin typeface="Times New Roman"/>
               </a:rPr>
-              <a:t>Accept with a note when one duplicate well is flagged and the rest agree</a:t>
+              <a:t>Exclude a flagged well only under the protocol; confirm sufficient valid replicates remain</a:t>
             </a:r>
           </a:p>
         </p:txBody>
@@ -4619,7 +4619,7 @@
               <a:rPr sz="1800">
                 <a:latin typeface="Times New Roman"/>
               </a:rPr>
-              <a:t>Rerun when a control is outside the window</a:t>
+              <a:t>Hold or rerun a plate that fails a control or reference-response criterion</a:t>
             </a:r>
           </a:p>
           <a:p>
@@ -4628,7 +4628,7 @@
               <a:rPr sz="1800">
                 <a:latin typeface="Times New Roman"/>
               </a:rPr>
-              <a:t>Rerun when the edge wells are the only failures and the reference is off</a:t>
+              <a:t>Investigate edge effects even when the reference response is acceptable</a:t>
             </a:r>
           </a:p>
           <a:p>
@@ -4637,7 +4637,7 @@
               <a:rPr sz="1800">
                 <a:latin typeface="Times New Roman"/>
               </a:rPr>
-              <a:t>Escalate to the study director after a second failure on the same test lot</a:t>
+              <a:t>Refer unresolved or repeated failures to the study director</a:t>
             </a:r>
           </a:p>
         </p:txBody>
@@ -4914,7 +4914,7 @@
                         <a:rPr sz="1400">
                           <a:latin typeface="Times New Roman"/>
                         </a:rPr>
-                        <a:t>Positive control</a:t>
+                        <a:t>Positive and negative controls</a:t>
                       </a:r>
                     </a:p>
                   </a:txBody>
@@ -4929,7 +4929,7 @@
                         <a:rPr sz="1400">
                           <a:latin typeface="Times New Roman"/>
                         </a:rPr>
-                        <a:t>Inside the window across all duplicates</a:t>
+                        <a:t>Meet protocol limits and replicate requirements</a:t>
                       </a:r>
                     </a:p>
                   </a:txBody>
@@ -4944,54 +4944,7 @@
                         <a:rPr sz="1400">
                           <a:latin typeface="Times New Roman"/>
                         </a:rPr>
-                        <a:t>Rerun the plate</a:t>
-                      </a:r>
-                    </a:p>
-                  </a:txBody>
-                  <a:tcPr/>
-                </a:tc>
-              </a:tr>
-              <a:tr h="274320">
-                <a:tc>
-                  <a:txBody>
-                    <a:bodyPr/>
-                    <a:lstStyle/>
-                    <a:p>
-                      <a:r>
-                        <a:rPr sz="1400">
-                          <a:latin typeface="Times New Roman"/>
-                        </a:rPr>
-                        <a:t>Negative control</a:t>
-                      </a:r>
-                    </a:p>
-                  </a:txBody>
-                  <a:tcPr/>
-                </a:tc>
-                <a:tc>
-                  <a:txBody>
-                    <a:bodyPr/>
-                    <a:lstStyle/>
-                    <a:p>
-                      <a:r>
-                        <a:rPr sz="1400">
-                          <a:latin typeface="Times New Roman"/>
-                        </a:rPr>
-                        <a:t>Low signal, no edge effect</a:t>
-                      </a:r>
-                    </a:p>
-                  </a:txBody>
-                  <a:tcPr/>
-                </a:tc>
-                <a:tc>
-                  <a:txBody>
-                    <a:bodyPr/>
-                    <a:lstStyle/>
-                    <a:p>
-                      <a:r>
-                        <a:rPr sz="1400">
-                          <a:latin typeface="Times New Roman"/>
-                        </a:rPr>
-                        <a:t>Rerun; check the reagent lot</a:t>
+                        <a:t>Hold; investigate and rerun if required</a:t>
                       </a:r>
                     </a:p>
                   </a:txBody>
@@ -5023,7 +4976,7 @@
                         <a:rPr sz="1400">
                           <a:latin typeface="Times New Roman"/>
                         </a:rPr>
-                        <a:t>On its curve, same potency range as the last set</a:t>
+                        <a:t>Meets protocol potency and curve-quality limits</a:t>
                       </a:r>
                     </a:p>
                   </a:txBody>
@@ -5038,7 +4991,54 @@
                         <a:rPr sz="1400">
                           <a:latin typeface="Times New Roman"/>
                         </a:rPr>
-                        <a:t>Rerun; tell the assay quality coordinator</a:t>
+                        <a:t>Hold; tell the assay quality coordinator</a:t>
+                      </a:r>
+                    </a:p>
+                  </a:txBody>
+                  <a:tcPr/>
+                </a:tc>
+              </a:tr>
+              <a:tr h="274320">
+                <a:tc>
+                  <a:txBody>
+                    <a:bodyPr/>
+                    <a:lstStyle/>
+                    <a:p>
+                      <a:r>
+                        <a:rPr sz="1400">
+                          <a:latin typeface="Times New Roman"/>
+                        </a:rPr>
+                        <a:t>Flagged wells</a:t>
+                      </a:r>
+                    </a:p>
+                  </a:txBody>
+                  <a:tcPr/>
+                </a:tc>
+                <a:tc>
+                  <a:txBody>
+                    <a:bodyPr/>
+                    <a:lstStyle/>
+                    <a:p>
+                      <a:r>
+                        <a:rPr sz="1400">
+                          <a:latin typeface="Times New Roman"/>
+                        </a:rPr>
+                        <a:t>Exclusion permitted by protocol; enough valid replicates remain</a:t>
+                      </a:r>
+                    </a:p>
+                  </a:txBody>
+                  <a:tcPr/>
+                </a:tc>
+                <a:tc>
+                  <a:txBody>
+                    <a:bodyPr/>
+                    <a:lstStyle/>
+                    <a:p>
+                      <a:r>
+                        <a:rPr sz="1400">
+                          <a:latin typeface="Times New Roman"/>
+                        </a:rPr>
+                        <a:t>Hold or rerun affected results</a:t>
                       </a:r>
                     </a:p>
                   </a:txBody>
@@ -5070,7 +5070,7 @@
                         <a:rPr sz="1400">
                           <a:latin typeface="Times New Roman"/>
                         </a:rPr>
-                        <a:t>No step change between plates</a:t>
+                        <a:t>Meets protocol drift criteria after investigation</a:t>
                       </a:r>
                     </a:p>
                   </a:txBody>
@@ -5085,7 +5085,7 @@
                         <a:rPr sz="1400">
                           <a:latin typeface="Times New Roman"/>
                         </a:rPr>
-                        <a:t>Hold the set; check the lot record</a:t>
+                        <a:t>Hold the affected set; check run records</a:t>
                       </a:r>
                     </a:p>
                   </a:txBody>
@@ -5255,7 +5255,7 @@
               <a:rPr sz="2000">
                 <a:latin typeface="Times New Roman"/>
               </a:rPr>
-              <a:t>One rerun per plate with the same compound plate</a:t>
+              <a:t>Rerun failed plates according to the assay protocol after investigating the failure</a:t>
             </a:r>
           </a:p>
           <a:p>
@@ -5264,7 +5264,7 @@
               <a:rPr sz="2000">
                 <a:latin typeface="Times New Roman"/>
               </a:rPr>
-              <a:t>A second failure goes to the study director with the run sheet attached</a:t>
+              <a:t>Refer repeated failures to the study director with the run sheet attached</a:t>
             </a:r>
           </a:p>
           <a:p>
@@ -5273,7 +5273,7 @@
               <a:rPr sz="1700">
                 <a:latin typeface="Times New Roman"/>
               </a:rPr>
-              <a:t>Do not mix a rerun plate into the original set without a note</a:t>
+              <a:t>Link the repeat to the original run and retain both records</a:t>
             </a:r>
           </a:p>
           <a:p>
@@ -5282,7 +5282,7 @@
               <a:rPr sz="2000">
                 <a:latin typeface="Times New Roman"/>
               </a:rPr>
-              <a:t>Excluded plates stay on the record with the reason</a:t>
+              <a:t>Do not average failed-run results into accepted potency estimates</a:t>
             </a:r>
           </a:p>
         </p:txBody>

</xml_diff>